<commit_message>
Add compose authoring and layout inspect exports
Keep stable experience-slide names for artifact-tool targeting, write
per-slide layout JSON and NDJSON inspect, and tighten the opening slide
so the three point cards sit closer to the body copy.

Co-authored-by: kristinehina23-rgb <kristinehina23-rgb@users.noreply.github.com>
</commit_message>
<xml_diff>
--- a/freshman-share-2026/outputs/喜娜_中大本科新生分享_丰富经历照片终版_2026.pptx
+++ b/freshman-share-2026/outputs/喜娜_中大本科新生分享_丰富经历照片终版_2026.pptx
@@ -4820,8 +4820,8 @@
         </p:nvSpPr>
         <p:spPr>
           <a:xfrm>
-            <a:off x="548640" y="3840480"/>
-            <a:ext cx="3657600" cy="2011680"/>
+            <a:off x="548640" y="3520440"/>
+            <a:ext cx="3657600" cy="2331720"/>
           </a:xfrm>
           <a:prstGeom prst="rect">
             <a:avLst/>
@@ -4863,8 +4863,8 @@
         </p:nvSpPr>
         <p:spPr>
           <a:xfrm>
-            <a:off x="548640" y="3840480"/>
-            <a:ext cx="64008" cy="2011680"/>
+            <a:off x="548640" y="3520440"/>
+            <a:ext cx="64008" cy="2331720"/>
           </a:xfrm>
           <a:prstGeom prst="rect">
             <a:avLst/>
@@ -4906,7 +4906,7 @@
         </p:nvSpPr>
         <p:spPr>
           <a:xfrm>
-            <a:off x="777240" y="3977639"/>
+            <a:off x="777240" y="3703320"/>
             <a:ext cx="3200400" cy="320040"/>
           </a:xfrm>
           <a:prstGeom prst="rect">
@@ -4943,8 +4943,8 @@
         </p:nvSpPr>
         <p:spPr>
           <a:xfrm>
-            <a:off x="777240" y="4389120"/>
-            <a:ext cx="3200400" cy="1188720"/>
+            <a:off x="777240" y="4114800"/>
+            <a:ext cx="3200400" cy="1463040"/>
           </a:xfrm>
           <a:prstGeom prst="rect">
             <a:avLst/>
@@ -4980,8 +4980,8 @@
         </p:nvSpPr>
         <p:spPr>
           <a:xfrm>
-            <a:off x="4389120" y="3840480"/>
-            <a:ext cx="3657600" cy="2011680"/>
+            <a:off x="4389120" y="3520440"/>
+            <a:ext cx="3657600" cy="2331720"/>
           </a:xfrm>
           <a:prstGeom prst="rect">
             <a:avLst/>
@@ -5023,8 +5023,8 @@
         </p:nvSpPr>
         <p:spPr>
           <a:xfrm>
-            <a:off x="4389120" y="3840480"/>
-            <a:ext cx="64008" cy="2011680"/>
+            <a:off x="4389120" y="3520440"/>
+            <a:ext cx="64008" cy="2331720"/>
           </a:xfrm>
           <a:prstGeom prst="rect">
             <a:avLst/>
@@ -5066,7 +5066,7 @@
         </p:nvSpPr>
         <p:spPr>
           <a:xfrm>
-            <a:off x="4617720" y="3977639"/>
+            <a:off x="4617720" y="3703320"/>
             <a:ext cx="3200400" cy="320040"/>
           </a:xfrm>
           <a:prstGeom prst="rect">
@@ -5103,8 +5103,8 @@
         </p:nvSpPr>
         <p:spPr>
           <a:xfrm>
-            <a:off x="4617720" y="4389120"/>
-            <a:ext cx="3200400" cy="1188720"/>
+            <a:off x="4617720" y="4114800"/>
+            <a:ext cx="3200400" cy="1463040"/>
           </a:xfrm>
           <a:prstGeom prst="rect">
             <a:avLst/>
@@ -5140,8 +5140,8 @@
         </p:nvSpPr>
         <p:spPr>
           <a:xfrm>
-            <a:off x="8229600" y="3840480"/>
-            <a:ext cx="3657600" cy="2011680"/>
+            <a:off x="8229600" y="3520440"/>
+            <a:ext cx="3657600" cy="2331720"/>
           </a:xfrm>
           <a:prstGeom prst="rect">
             <a:avLst/>
@@ -5183,8 +5183,8 @@
         </p:nvSpPr>
         <p:spPr>
           <a:xfrm>
-            <a:off x="8229600" y="3840480"/>
-            <a:ext cx="64008" cy="2011680"/>
+            <a:off x="8229600" y="3520440"/>
+            <a:ext cx="64008" cy="2331720"/>
           </a:xfrm>
           <a:prstGeom prst="rect">
             <a:avLst/>
@@ -5226,7 +5226,7 @@
         </p:nvSpPr>
         <p:spPr>
           <a:xfrm>
-            <a:off x="8458200" y="3977639"/>
+            <a:off x="8458200" y="3703320"/>
             <a:ext cx="3200400" cy="320040"/>
           </a:xfrm>
           <a:prstGeom prst="rect">
@@ -5263,8 +5263,8 @@
         </p:nvSpPr>
         <p:spPr>
           <a:xfrm>
-            <a:off x="8458200" y="4389120"/>
-            <a:ext cx="3200400" cy="1188720"/>
+            <a:off x="8458200" y="4114800"/>
+            <a:ext cx="3200400" cy="1463040"/>
           </a:xfrm>
           <a:prstGeom prst="rect">
             <a:avLst/>

</xml_diff>